<commit_message>
Rewrite audio slide scripts to explain what and why
The audio notes were mostly results with project-history asides. They now
explain the pieces for an audience that has not met them: what MFCCs and
a CNN are, what WavLM is and why self-supervised pre-training suits a
small labelled set, how it is fine-tuned, what macro-F1 measures and why
it is used, and why the split is by speaker. Project-history references
are removed. Notes only; no slide content changed.

Claude-Session: https://claude.ai/code/session_01PpjoBkUkre2feHhgfqk7aN
</commit_message>
<xml_diff>
--- a/presentation/Sept_eval_1_multimodal.pptx
+++ b/presentation/Sept_eval_1_multimodal.pptx
@@ -2457,106 +2457,189 @@
           <a:lstStyle/>
           <a:p>
             <a:r>
-              <a:t>REBUILDING THE AUDIO CORPUS (75s)</a:t>
+              <a:t>AUDIO, PART 1 - THE DATA (2 min)</a:t>
             </a:r>
           </a:p>
           <a:p/>
           <a:p>
             <a:r>
-              <a:t>This slide is about a problem we inherited and had to fix before any</a:t>
-            </a:r>
-          </a:p>
-          <a:p>
-            <a:r>
-              <a:t>audio number meant anything.</a:t>
+              <a:t>Start with the task, in one sentence: "For voice, we take about four</a:t>
+            </a:r>
+          </a:p>
+          <a:p>
+            <a:r>
+              <a:t>seconds of someone talking and ask which of seven emotions it sounds</a:t>
+            </a:r>
+          </a:p>
+          <a:p>
+            <a:r>
+              <a:t>like - not WHAT they said, but HOW they said it: pitch, loudness, speed,</a:t>
+            </a:r>
+          </a:p>
+          <a:p>
+            <a:r>
+              <a:t>pauses, strain in the voice."</a:t>
             </a:r>
           </a:p>
           <a:p/>
           <a:p>
             <a:r>
-              <a:t>The earlier branch shipped an audio model that had never been trained -</a:t>
-            </a:r>
-          </a:p>
-          <a:p>
-            <a:r>
-              <a:t>the notebook stopped before the training cell - on a corpus missing two</a:t>
-            </a:r>
-          </a:p>
-          <a:p>
-            <a:r>
-              <a:t>of the seven emotions. No neutral and no disgust, and an 8.6-to-1</a:t>
-            </a:r>
-          </a:p>
-          <a:p>
-            <a:r>
-              <a:t>imbalance on surprise. A model that cannot emit "neutral" will label</a:t>
-            </a:r>
-          </a:p>
-          <a:p>
-            <a:r>
-              <a:t>silence as whatever its prior favours, on every single frame. Neutral is</a:t>
-            </a:r>
-          </a:p>
-          <a:p>
-            <a:r>
-              <a:t>the resting state of a real consultation, so that is fatal, not</a:t>
-            </a:r>
-          </a:p>
-          <a:p>
-            <a:r>
-              <a:t>cosmetic.</a:t>
+              <a:t>To teach a model that, you need recordings someone has already labelled.</a:t>
+            </a:r>
+          </a:p>
+          <a:p>
+            <a:r>
+              <a:t>We combined four public collections, about 23,000 clips:</a:t>
             </a:r>
           </a:p>
           <a:p/>
           <a:p>
             <a:r>
-              <a:t>So we rebuilt it from four corpora - CREMA-D, RAVDESS, SAVEE and MELD -</a:t>
-            </a:r>
-          </a:p>
-          <a:p>
-            <a:r>
-              <a:t>about 23,000 clips covering all seven classes.</a:t>
+              <a:t> - CREMA-D, RAVDESS and SAVEE: actors in a studio performing the same</a:t>
+            </a:r>
+          </a:p>
+          <a:p>
+            <a:r>
+              <a:t>   sentences in different emotions. Clean and clearly labelled, but</a:t>
+            </a:r>
+          </a:p>
+          <a:p>
+            <a:r>
+              <a:t>   acted.</a:t>
+            </a:r>
+          </a:p>
+          <a:p>
+            <a:r>
+              <a:t> - MELD: clips cut from the TV show Friends. Real conversation,</a:t>
+            </a:r>
+          </a:p>
+          <a:p>
+            <a:r>
+              <a:t>   overlapping voices, a laugh track, background noise. Messy, but much</a:t>
+            </a:r>
+          </a:p>
+          <a:p>
+            <a:r>
+              <a:t>   closer to a real consultation.</a:t>
             </a:r>
           </a:p>
           <a:p/>
           <a:p>
             <a:r>
-              <a:t>The methodological point is the caption, and I want to dwell on it. We</a:t>
-            </a:r>
-          </a:p>
-          <a:p>
-            <a:r>
-              <a:t>split by SPEAKER, not by clip. Every acted corpus has each actor perform</a:t>
-            </a:r>
-          </a:p>
-          <a:p>
-            <a:r>
-              <a:t>every emotion on the same sentences. If you split randomly, the same</a:t>
-            </a:r>
-          </a:p>
-          <a:p>
-            <a:r>
-              <a:t>actor's voice appears in train and test, and the model can score by</a:t>
-            </a:r>
-          </a:p>
-          <a:p>
-            <a:r>
-              <a:t>recognising the voice rather than the emotion. That is worth fifteen to</a:t>
-            </a:r>
-          </a:p>
-          <a:p>
-            <a:r>
-              <a:t>twenty-five points, and it is why a lot of published speech-emotion</a:t>
-            </a:r>
-          </a:p>
-          <a:p>
-            <a:r>
-              <a:t>numbers look high. Our numbers are lower than the literature partly</a:t>
-            </a:r>
-          </a:p>
-          <a:p>
-            <a:r>
-              <a:t>because of this choice, and we would make it again.</a:t>
+              <a:t>We used both on purpose. Studio data teaches the model what each emotion</a:t>
+            </a:r>
+          </a:p>
+          <a:p>
+            <a:r>
+              <a:t>sounds like when it is clear. MELD tells us whether it still works when</a:t>
+            </a:r>
+          </a:p>
+          <a:p>
+            <a:r>
+              <a:t>it is not.</a:t>
+            </a:r>
+          </a:p>
+          <a:p/>
+          <a:p>
+            <a:r>
+              <a:t>WHY ALL SEVEN EMOTIONS MATTERS. Our first attempt used a narrower set:</a:t>
+            </a:r>
+          </a:p>
+          <a:p>
+            <a:r>
+              <a:t>five emotions, no neutral, no disgust. Neutral is what most of a real</a:t>
+            </a:r>
+          </a:p>
+          <a:p>
+            <a:r>
+              <a:t>consultation sounds like. A model that has never heard calm speech has</a:t>
+            </a:r>
+          </a:p>
+          <a:p>
+            <a:r>
+              <a:t>nowhere to put it, so it forces every calm moment into one of the</a:t>
+            </a:r>
+          </a:p>
+          <a:p>
+            <a:r>
+              <a:t>emotions it does know. Covering all seven was not tidiness, it was the</a:t>
+            </a:r>
+          </a:p>
+          <a:p>
+            <a:r>
+              <a:t>difference between a model that can rest and one that cannot.</a:t>
+            </a:r>
+          </a:p>
+          <a:p/>
+          <a:p>
+            <a:r>
+              <a:t>WHY WE SPLIT BY SPEAKER (the most important point on this slide). In</a:t>
+            </a:r>
+          </a:p>
+          <a:p>
+            <a:r>
+              <a:t>acted datasets, every actor says the same sentences in every emotion. If</a:t>
+            </a:r>
+          </a:p>
+          <a:p>
+            <a:r>
+              <a:t>you shuffle clips randomly, the same person ends up in both training and</a:t>
+            </a:r>
+          </a:p>
+          <a:p>
+            <a:r>
+              <a:t>testing, and the model can score well just by recognising "that is actor</a:t>
+            </a:r>
+          </a:p>
+          <a:p>
+            <a:r>
+              <a:t>twelve's voice". It is memorising people, not learning emotion. A</a:t>
+            </a:r>
+          </a:p>
+          <a:p>
+            <a:r>
+              <a:t>speaker-disjoint split means every voice in the test set is someone the</a:t>
+            </a:r>
+          </a:p>
+          <a:p>
+            <a:r>
+              <a:t>model has never heard. The numbers come out lower, but they are the</a:t>
+            </a:r>
+          </a:p>
+          <a:p>
+            <a:r>
+              <a:t>numbers you would get on a NEW patient - which is the only case we care</a:t>
+            </a:r>
+          </a:p>
+          <a:p>
+            <a:r>
+              <a:t>about. This one choice is a big part of why published speech-emotion</a:t>
+            </a:r>
+          </a:p>
+          <a:p>
+            <a:r>
+              <a:t>figures often look higher than ours.</a:t>
+            </a:r>
+          </a:p>
+          <a:p/>
+          <a:p>
+            <a:r>
+              <a:t>ONE MORE DETAIL. We normalise the loudness of every clip. Datasets are</a:t>
+            </a:r>
+          </a:p>
+          <a:p>
+            <a:r>
+              <a:t>recorded at different volumes - SAVEE is loud, MELD is quiet under the</a:t>
+            </a:r>
+          </a:p>
+          <a:p>
+            <a:r>
+              <a:t>laugh track. Without this, the model could learn "quiet means MELD" and</a:t>
+            </a:r>
+          </a:p>
+          <a:p>
+            <a:r>
+              <a:t>identify the dataset instead of the emotion.</a:t>
             </a:r>
           </a:p>
         </p:txBody>
@@ -2626,86 +2709,378 @@
           <a:lstStyle/>
           <a:p>
             <a:r>
-              <a:t>AUDIO RESULTS (75s)</a:t>
+              <a:t>AUDIO, PART 2 - THE MODEL AND THE RESULT (3 min)</a:t>
             </a:r>
           </a:p>
           <a:p/>
           <a:p>
             <a:r>
-              <a:t>Speaker-disjoint test split, 4,179 clips, seven classes, so chance is</a:t>
-            </a:r>
-          </a:p>
-          <a:p>
-            <a:r>
-              <a:t>14.3%.</a:t>
+              <a:t>Two models, same data, same speaker-disjoint split. Only the model</a:t>
+            </a:r>
+          </a:p>
+          <a:p>
+            <a:r>
+              <a:t>changes.</a:t>
             </a:r>
           </a:p>
           <a:p/>
           <a:p>
             <a:r>
-              <a:t>The baseline bar is the earlier branch's own MFCC CNN architecture,</a:t>
-            </a:r>
-          </a:p>
-          <a:p>
-            <a:r>
-              <a:t>imported unchanged and retrained on the same rebuilt data. Same data,</a:t>
-            </a:r>
-          </a:p>
-          <a:p>
-            <a:r>
-              <a:t>same splits - so the 17.7-point gap isolates the model from the</a:t>
-            </a:r>
-          </a:p>
-          <a:p>
-            <a:r>
-              <a:t>dataset. 0.322 macro-F1 to 0.499.</a:t>
+              <a:t>THE BASELINE: MFCC + a small CNN. MFCC stands for Mel-frequency cepstral</a:t>
+            </a:r>
+          </a:p>
+          <a:p>
+            <a:r>
+              <a:t>coefficients. It is a hand-designed summary of sound: cut the audio into</a:t>
+            </a:r>
+          </a:p>
+          <a:p>
+            <a:r>
+              <a:t>tiny slices and describe each slice with 40 numbers that capture its</a:t>
+            </a:r>
+          </a:p>
+          <a:p>
+            <a:r>
+              <a:t>spectral shape, on a scale that mimics how human hearing works. Laid</a:t>
+            </a:r>
+          </a:p>
+          <a:p>
+            <a:r>
+              <a:t>side by side, those numbers make a picture - time across, frequency</a:t>
+            </a:r>
+          </a:p>
+          <a:p>
+            <a:r>
+              <a:t>down - and a small CNN, about 390,000 parameters, looks for patterns in</a:t>
+            </a:r>
+          </a:p>
+          <a:p>
+            <a:r>
+              <a:t>that picture. It is very fast, about half a millisecond. The weakness is</a:t>
+            </a:r>
+          </a:p>
+          <a:p>
+            <a:r>
+              <a:t>that the summary is fixed. Someone decided in advance what to keep, and</a:t>
+            </a:r>
+          </a:p>
+          <a:p>
+            <a:r>
+              <a:t>subtle cues like vocal strain or how pitch rises and falls can be thrown</a:t>
+            </a:r>
+          </a:p>
+          <a:p>
+            <a:r>
+              <a:t>away before the model ever sees them.</a:t>
             </a:r>
           </a:p>
           <a:p/>
           <a:p>
             <a:r>
-              <a:t>Now the part I would rather you hear from me than find in the appendix.</a:t>
-            </a:r>
-          </a:p>
-          <a:p>
-            <a:r>
-              <a:t>The averaged number hides the real finding. Broken out by domain: 69.4%</a:t>
-            </a:r>
-          </a:p>
-          <a:p>
-            <a:r>
-              <a:t>accuracy on acted studio speech, 35.6% on MELD - real dialogue from a TV</a:t>
-            </a:r>
-          </a:p>
-          <a:p>
-            <a:r>
-              <a:t>show, with background noise and a laugh track. Studio speech works. A</a:t>
-            </a:r>
-          </a:p>
-          <a:p>
-            <a:r>
-              <a:t>noisy room is still hard.</a:t>
+              <a:t>OUR CHOICE: WavLM-base-plus. WavLM is a speech transformer from</a:t>
+            </a:r>
+          </a:p>
+          <a:p>
+            <a:r>
+              <a:t>Microsoft. Before it ever saw an emotion label, it was pre-trained on</a:t>
+            </a:r>
+          </a:p>
+          <a:p>
+            <a:r>
+              <a:t>about 94,000 hours of speech with a fill-in-the-blank task: hide small</a:t>
+            </a:r>
+          </a:p>
+          <a:p>
+            <a:r>
+              <a:t>chunks of the audio and make the model work out what was missing. The</a:t>
+            </a:r>
+          </a:p>
+          <a:p>
+            <a:r>
+              <a:t>training audio was also deliberately mixed with noise and overlapping</a:t>
+            </a:r>
+          </a:p>
+          <a:p>
+            <a:r>
+              <a:t>voices, so it is built to cope with messy conditions - which is exactly</a:t>
+            </a:r>
+          </a:p>
+          <a:p>
+            <a:r>
+              <a:t>what a video call is.</a:t>
             </a:r>
           </a:p>
           <a:p/>
           <a:p>
             <a:r>
-              <a:t>And the fusion is told the harder number. The per-class reliabilities we</a:t>
-            </a:r>
-          </a:p>
-          <a:p>
-            <a:r>
-              <a:t>feed the pool come from the wild domain, not the acted one, so the</a:t>
-            </a:r>
-          </a:p>
-          <a:p>
-            <a:r>
-              <a:t>system does not over-trust the voice in exactly the conditions a real</a:t>
-            </a:r>
-          </a:p>
-          <a:p>
-            <a:r>
-              <a:t>consultation resembles.</a:t>
+              <a:t>To do that task well, the model has to learn how speech works: pitch,</a:t>
+            </a:r>
+          </a:p>
+          <a:p>
+            <a:r>
+              <a:t>rhythm, timbre, pauses. So by the time it reaches us it already</a:t>
+            </a:r>
+          </a:p>
+          <a:p>
+            <a:r>
+              <a:t>understands voices. Our 4,179 test clips and the training set behind</a:t>
+            </a:r>
+          </a:p>
+          <a:p>
+            <a:r>
+              <a:t>them could never teach that from scratch. All we teach it is which</a:t>
+            </a:r>
+          </a:p>
+          <a:p>
+            <a:r>
+              <a:t>patterns mean which emotion. That is the whole reason to use a</a:t>
+            </a:r>
+          </a:p>
+          <a:p>
+            <a:r>
+              <a:t>pre-trained model: we are borrowing 94,000 hours of listening.</a:t>
+            </a:r>
+          </a:p>
+          <a:p/>
+          <a:p>
+            <a:r>
+              <a:t>HOW WE FINE-TUNE IT, in plain terms:</a:t>
+            </a:r>
+          </a:p>
+          <a:p>
+            <a:r>
+              <a:t> - the low-level audio front end stays frozen;</a:t>
+            </a:r>
+          </a:p>
+          <a:p>
+            <a:r>
+              <a:t> - the transformer is nudged gently, with a small learning rate, so it</a:t>
+            </a:r>
+          </a:p>
+          <a:p>
+            <a:r>
+              <a:t>   does not forget what it knows;</a:t>
+            </a:r>
+          </a:p>
+          <a:p>
+            <a:r>
+              <a:t> - the new classification layer on top learns faster, because it starts</a:t>
+            </a:r>
+          </a:p>
+          <a:p>
+            <a:r>
+              <a:t>   from nothing.</a:t>
+            </a:r>
+          </a:p>
+          <a:p/>
+          <a:p>
+            <a:r>
+              <a:t>And instead of reading only the last layer, we let the model learn a</a:t>
+            </a:r>
+          </a:p>
+          <a:p>
+            <a:r>
+              <a:t>weighted blend of all its layers. Different layers hold different</a:t>
+            </a:r>
+          </a:p>
+          <a:p>
+            <a:r>
+              <a:t>information: the top layers are tuned to the pre-training task of</a:t>
+            </a:r>
+          </a:p>
+          <a:p>
+            <a:r>
+              <a:t>predicting what was said, so they tend to keep less of how it was said.</a:t>
+            </a:r>
+          </a:p>
+          <a:p>
+            <a:r>
+              <a:t>The learned blend leans mildly toward the middle-to-upper layers rather</a:t>
+            </a:r>
+          </a:p>
+          <a:p>
+            <a:r>
+              <a:t>than the very top, which is what you would expect.</a:t>
+            </a:r>
+          </a:p>
+          <a:p/>
+          <a:p>
+            <a:r>
+              <a:t>THE RESULT. Macro-F1 goes from 0.322 to 0.499, a 17.7-point gap. Because</a:t>
+            </a:r>
+          </a:p>
+          <a:p>
+            <a:r>
+              <a:t>the data and the split are identical, that gap belongs to the model</a:t>
+            </a:r>
+          </a:p>
+          <a:p>
+            <a:r>
+              <a:t>alone. Say what macro-F1 is: the average of the per-emotion scores, so</a:t>
+            </a:r>
+          </a:p>
+          <a:p>
+            <a:r>
+              <a:t>every emotion counts equally. We use it because neutral is nearly half</a:t>
+            </a:r>
+          </a:p>
+          <a:p>
+            <a:r>
+              <a:t>of MELD - a lazy model that always answered "neutral" would look</a:t>
+            </a:r>
+          </a:p>
+          <a:p>
+            <a:r>
+              <a:t>respectable on plain accuracy and score about 0.09 on macro-F1. Chance</a:t>
+            </a:r>
+          </a:p>
+          <a:p>
+            <a:r>
+              <a:t>level for seven classes is 14.3%.</a:t>
+            </a:r>
+          </a:p>
+          <a:p/>
+          <a:p>
+            <a:r>
+              <a:t>THE HONEST PART. Averaged, the number hides the real finding. On acted</a:t>
+            </a:r>
+          </a:p>
+          <a:p>
+            <a:r>
+              <a:t>studio speech the model is right about 69% of the time. On real</a:t>
+            </a:r>
+          </a:p>
+          <a:p>
+            <a:r>
+              <a:t>conversation it is about 36%. Studio speech works; a noisy room is still</a:t>
+            </a:r>
+          </a:p>
+          <a:p>
+            <a:r>
+              <a:t>hard - and humans disagree about emotion in TV dialogue too. The weakest</a:t>
+            </a:r>
+          </a:p>
+          <a:p>
+            <a:r>
+              <a:t>classes are fear and disgust, which have very few examples in real</a:t>
+            </a:r>
+          </a:p>
+          <a:p>
+            <a:r>
+              <a:t>speech (50 and 68 test clips), so the model barely learns them.</a:t>
+            </a:r>
+          </a:p>
+          <a:p/>
+          <a:p>
+            <a:r>
+              <a:t>HOW THE SYSTEM USES THIS. The fusion is given the harder, real-speech</a:t>
+            </a:r>
+          </a:p>
+          <a:p>
+            <a:r>
+              <a:t>numbers, not the studio ones, so it does not over-trust the voice in</a:t>
+            </a:r>
+          </a:p>
+          <a:p>
+            <a:r>
+              <a:t>exactly the conditions a consultation resembles. It also only counts the</a:t>
+            </a:r>
+          </a:p>
+          <a:p>
+            <a:r>
+              <a:t>voice while someone is actually speaking, and a reading fades within</a:t>
+            </a:r>
+          </a:p>
+          <a:p>
+            <a:r>
+              <a:t>seconds so a stale one cannot linger.</a:t>
+            </a:r>
+          </a:p>
+          <a:p/>
+          <a:p>
+            <a:r>
+              <a:t>COST. About 95 million parameters, about 16 milliseconds per four-second</a:t>
+            </a:r>
+          </a:p>
+          <a:p>
+            <a:r>
+              <a:t>window, scored roughly once a second. Cheap enough to run live. It is</a:t>
+            </a:r>
+          </a:p>
+          <a:p>
+            <a:r>
+              <a:t>also the heaviest of our three models in memory, so it only loads if the</a:t>
+            </a:r>
+          </a:p>
+          <a:p>
+            <a:r>
+              <a:t>microphone is used.</a:t>
+            </a:r>
+          </a:p>
+          <a:p/>
+          <a:p>
+            <a:r>
+              <a:t>IF ASKED:</a:t>
+            </a:r>
+          </a:p>
+          <a:p>
+            <a:r>
+              <a:t> - "Why WavLM and not another speech model?" We measured it against the</a:t>
+            </a:r>
+          </a:p>
+          <a:p>
+            <a:r>
+              <a:t>   classic MFCC approach. We did not benchmark other pre-trained speech</a:t>
+            </a:r>
+          </a:p>
+          <a:p>
+            <a:r>
+              <a:t>   models, so do not claim it beats them. We chose WavLM because it was</a:t>
+            </a:r>
+          </a:p>
+          <a:p>
+            <a:r>
+              <a:t>   built for noisy, overlapping speech and was evaluated across the</a:t>
+            </a:r>
+          </a:p>
+          <a:p>
+            <a:r>
+              <a:t>   standard SUPERB speech benchmark, which includes emotion recognition.</a:t>
+            </a:r>
+          </a:p>
+          <a:p>
+            <a:r>
+              <a:t>   Comparing others is future work.</a:t>
+            </a:r>
+          </a:p>
+          <a:p>
+            <a:r>
+              <a:t> - "36% is below always guessing neutral (48%)." True for plain</a:t>
+            </a:r>
+          </a:p>
+          <a:p>
+            <a:r>
+              <a:t>   accuracy, which is why we report macro-F1. The model is trained with</a:t>
+            </a:r>
+          </a:p>
+          <a:p>
+            <a:r>
+              <a:t>   class weights so it does not collapse onto neutral; macro-F1 of 0.25</a:t>
+            </a:r>
+          </a:p>
+          <a:p>
+            <a:r>
+              <a:t>   on real speech against about 0.09 for always-neutral.</a:t>
+            </a:r>
+          </a:p>
+          <a:p>
+            <a:r>
+              <a:t> - "Papers report 90%+." Mostly random clip splits, where the same</a:t>
+            </a:r>
+          </a:p>
+          <a:p>
+            <a:r>
+              <a:t>   speaker is in training and test. Ours are speaker-disjoint.</a:t>
             </a:r>
           </a:p>
         </p:txBody>

</xml_diff>